<commit_message>
Beacon v2.3: 30s teaser + deck cosmetic polish (slides 2/4/7)
</commit_message>
<xml_diff>
--- a/products/beacon/docs/downloads/AIGovOps_Beacon_Pitch.pptx
+++ b/products/beacon/docs/downloads/AIGovOps_Beacon_Pitch.pptx
@@ -2626,7 +2626,7 @@
                 <a:ea typeface="Trebuchet MS" pitchFamily="34" charset="-122"/>
                 <a:cs typeface="Trebuchet MS" pitchFamily="34" charset="-120"/>
               </a:rPr>
-              <a:t>Twenty-three frameworks. One score command.</a:t>
+              <a:t>23 frameworks built in. Yours plugs right in.</a:t>
             </a:r>
             <a:endParaRPr lang="en-US" sz="3200" dirty="0"/>
           </a:p>
@@ -6742,8 +6742,8 @@
         </p:nvSpPr>
         <p:spPr>
           <a:xfrm>
-            <a:off x="655168" y="2286000"/>
-            <a:ext cx="3108960" cy="365760"/>
+            <a:off x="655168" y="2331720"/>
+            <a:ext cx="3108960" cy="320040"/>
           </a:xfrm>
           <a:prstGeom prst="rect">
             <a:avLst/>
@@ -6782,7 +6782,7 @@
         <p:spPr>
           <a:xfrm>
             <a:off x="655168" y="2743200"/>
-            <a:ext cx="3108960" cy="822960"/>
+            <a:ext cx="3108960" cy="777240"/>
           </a:xfrm>
           <a:prstGeom prst="rect">
             <a:avLst/>
@@ -6820,7 +6820,7 @@
         </p:nvSpPr>
         <p:spPr>
           <a:xfrm>
-            <a:off x="655168" y="3703320"/>
+            <a:off x="655168" y="3611880"/>
             <a:ext cx="3108960" cy="1920240"/>
           </a:xfrm>
           <a:prstGeom prst="rect">
@@ -6830,7 +6830,7 @@
           <a:ln/>
         </p:spPr>
         <p:txBody>
-          <a:bodyPr wrap="square" rtlCol="0" anchor="ctr"/>
+          <a:bodyPr wrap="square" rtlCol="0" anchor="t"/>
           <a:lstStyle/>
           <a:p>
             <a:pPr indent="0" marL="0">
@@ -6884,8 +6884,8 @@
         </p:nvSpPr>
         <p:spPr>
           <a:xfrm>
-            <a:off x="4541368" y="2286000"/>
-            <a:ext cx="3108960" cy="365760"/>
+            <a:off x="4541368" y="2331720"/>
+            <a:ext cx="3108960" cy="320040"/>
           </a:xfrm>
           <a:prstGeom prst="rect">
             <a:avLst/>
@@ -6924,7 +6924,7 @@
         <p:spPr>
           <a:xfrm>
             <a:off x="4541368" y="2743200"/>
-            <a:ext cx="3108960" cy="822960"/>
+            <a:ext cx="3108960" cy="777240"/>
           </a:xfrm>
           <a:prstGeom prst="rect">
             <a:avLst/>
@@ -6962,7 +6962,7 @@
         </p:nvSpPr>
         <p:spPr>
           <a:xfrm>
-            <a:off x="4541368" y="3703320"/>
+            <a:off x="4541368" y="3611880"/>
             <a:ext cx="3108960" cy="1920240"/>
           </a:xfrm>
           <a:prstGeom prst="rect">
@@ -6972,7 +6972,7 @@
           <a:ln/>
         </p:spPr>
         <p:txBody>
-          <a:bodyPr wrap="square" rtlCol="0" anchor="ctr"/>
+          <a:bodyPr wrap="square" rtlCol="0" anchor="t"/>
           <a:lstStyle/>
           <a:p>
             <a:pPr indent="0" marL="0">
@@ -7026,8 +7026,8 @@
         </p:nvSpPr>
         <p:spPr>
           <a:xfrm>
-            <a:off x="8427568" y="2286000"/>
-            <a:ext cx="3108960" cy="365760"/>
+            <a:off x="8427568" y="2331720"/>
+            <a:ext cx="3108960" cy="320040"/>
           </a:xfrm>
           <a:prstGeom prst="rect">
             <a:avLst/>
@@ -7066,7 +7066,7 @@
         <p:spPr>
           <a:xfrm>
             <a:off x="8427568" y="2743200"/>
-            <a:ext cx="3108960" cy="822960"/>
+            <a:ext cx="3108960" cy="777240"/>
           </a:xfrm>
           <a:prstGeom prst="rect">
             <a:avLst/>
@@ -7104,7 +7104,7 @@
         </p:nvSpPr>
         <p:spPr>
           <a:xfrm>
-            <a:off x="8427568" y="3703320"/>
+            <a:off x="8427568" y="3611880"/>
             <a:ext cx="3108960" cy="1920240"/>
           </a:xfrm>
           <a:prstGeom prst="rect">
@@ -7114,7 +7114,7 @@
           <a:ln/>
         </p:spPr>
         <p:txBody>
-          <a:bodyPr wrap="square" rtlCol="0" anchor="ctr"/>
+          <a:bodyPr wrap="square" rtlCol="0" anchor="t"/>
           <a:lstStyle/>
           <a:p>
             <a:pPr indent="0" marL="0">
@@ -8957,7 +8957,7 @@
                 <a:ea typeface="Calibri" pitchFamily="34" charset="-122"/>
                 <a:cs typeface="Calibri" pitchFamily="34" charset="-120"/>
               </a:rPr>
-              <a:t>Sign every prompt and response. Replay any conversation when legal asks.</a:t>
+              <a:t>Sign every prompt and response. Replay any conversation when legal asks for it.</a:t>
             </a:r>
             <a:endParaRPr lang="en-US" sz="1400" dirty="0"/>
           </a:p>
@@ -9060,7 +9060,7 @@
                 <a:ea typeface="Calibri" pitchFamily="34" charset="-122"/>
                 <a:cs typeface="Calibri" pitchFamily="34" charset="-120"/>
               </a:rPr>
-              <a:t>Bundle receipts per session. Hand them to regulators on demand.</a:t>
+              <a:t>Bundle receipts per session. Hand them to regulators on demand, without delay.</a:t>
             </a:r>
             <a:endParaRPr lang="en-US" sz="1400" dirty="0"/>
           </a:p>
@@ -9163,7 +9163,7 @@
                 <a:ea typeface="Calibri" pitchFamily="34" charset="-122"/>
                 <a:cs typeface="Calibri" pitchFamily="34" charset="-120"/>
               </a:rPr>
-              <a:t>Log routing decisions across agents. Detect drift between runs.</a:t>
+              <a:t>Log routing decisions across agents. Detect drift between runs, before users do.</a:t>
             </a:r>
             <a:endParaRPr lang="en-US" sz="1400" dirty="0"/>
           </a:p>
@@ -9266,7 +9266,7 @@
                 <a:ea typeface="Calibri" pitchFamily="34" charset="-122"/>
                 <a:cs typeface="Calibri" pitchFamily="34" charset="-120"/>
               </a:rPr>
-              <a:t>Lending, healthcare, hiring — every decision auditable and replayable.</a:t>
+              <a:t>Lending, healthcare, hiring — every decision auditable, verifiable, replayable.</a:t>
             </a:r>
             <a:endParaRPr lang="en-US" sz="1400" dirty="0"/>
           </a:p>
@@ -9369,7 +9369,7 @@
                 <a:ea typeface="Calibri" pitchFamily="34" charset="-122"/>
                 <a:cs typeface="Calibri" pitchFamily="34" charset="-120"/>
               </a:rPr>
-              <a:t>Track every model in production, with provenance, owners, and risk class.</a:t>
+              <a:t>Track every model in production, with provenance, owners, and a live risk class.</a:t>
             </a:r>
             <a:endParaRPr lang="en-US" sz="1400" dirty="0"/>
           </a:p>
@@ -9472,7 +9472,7 @@
                 <a:ea typeface="Calibri" pitchFamily="34" charset="-122"/>
                 <a:cs typeface="Calibri" pitchFamily="34" charset="-120"/>
               </a:rPr>
-              <a:t>Hand the auditor a bundle they can verify themselves. No portal logins.</a:t>
+              <a:t>Hand the auditor a bundle they can verify themselves. No portal logins required.</a:t>
             </a:r>
             <a:endParaRPr lang="en-US" sz="1400" dirty="0"/>
           </a:p>

</xml_diff>